<commit_message>
Finish multimodal interaction presentation v2
</commit_message>
<xml_diff>
--- a/产品/多模态交互竞品发展脉络-v2.pptx
+++ b/产品/多模态交互竞品发展脉络-v2.pptx
@@ -3177,7 +3177,7 @@
           <p:spPr>
             <a:xfrm>
               <a:off x="564642" y="4184650"/>
-              <a:ext cx="539382" cy="264033"/>
+              <a:ext cx="523540" cy="264033"/>
             </a:xfrm>
             <a:prstGeom prst="rect">
               <a:avLst/>
@@ -3203,7 +3203,7 @@
                   <a:ea typeface="+mj-ea"/>
                   <a:cs typeface="+mj-cs"/>
                 </a:rPr>
-                <a:t>Bixby</a:t>
+                <a:t>Muse</a:t>
               </a:r>
             </a:p>
           </p:txBody>
@@ -3217,7 +3217,7 @@
           <p:spPr>
             <a:xfrm>
               <a:off x="2280666" y="4235450"/>
-              <a:ext cx="1374705" cy="205359"/>
+              <a:ext cx="1741018" cy="205359"/>
             </a:xfrm>
             <a:prstGeom prst="rect">
               <a:avLst/>
@@ -3243,7 +3243,7 @@
                   <a:ea typeface="+mn-ea"/>
                   <a:cs typeface="+mn-cs"/>
                 </a:rPr>
-                <a:t>相机/相册/文档/圈屏</a:t>
+                <a:t>语音＋App/网页，后续眼镜</a:t>
               </a:r>
             </a:p>
           </p:txBody>
@@ -3257,7 +3257,7 @@
           <p:spPr>
             <a:xfrm>
               <a:off x="4757166" y="4235450"/>
-              <a:ext cx="1706880" cy="205359"/>
+              <a:ext cx="1784623" cy="205359"/>
             </a:xfrm>
             <a:prstGeom prst="rect">
               <a:avLst/>
@@ -3283,7 +3283,7 @@
                   <a:ea typeface="+mn-ea"/>
                   <a:cs typeface="+mn-cs"/>
                 </a:rPr>
-                <a:t>靠近系统任务；多设备生态</a:t>
+                <a:t>后台多步；支付/邮件需确认</a:t>
               </a:r>
             </a:p>
           </p:txBody>
@@ -3297,7 +3297,7 @@
           <p:spPr>
             <a:xfrm>
               <a:off x="7805166" y="4235450"/>
-              <a:ext cx="858774" cy="205359"/>
+              <a:ext cx="1282827" cy="205359"/>
             </a:xfrm>
             <a:prstGeom prst="rect">
               <a:avLst/>
@@ -3323,7 +3323,7 @@
                   <a:ea typeface="+mn-ea"/>
                   <a:cs typeface="+mn-cs"/>
                 </a:rPr>
-                <a:t>手机内容理解</a:t>
+                <a:t>购物、生产力、日历</a:t>
               </a:r>
             </a:p>
           </p:txBody>
@@ -3337,7 +3337,7 @@
           <p:spPr>
             <a:xfrm>
               <a:off x="10091547" y="4248150"/>
-              <a:ext cx="1065327" cy="191643"/>
+              <a:ext cx="1487495" cy="191643"/>
             </a:xfrm>
             <a:prstGeom prst="rect">
               <a:avLst/>
@@ -3357,13 +3357,13 @@
               <a:r>
                 <a:rPr lang="zh-CN" sz="980" dirty="0">
                   <a:solidFill>
-                    <a:srgbClr val="6B6760"/>
-                  </a:solidFill>
-                  <a:latin typeface="+mn-lt"/>
-                  <a:ea typeface="+mn-ea"/>
-                  <a:cs typeface="+mn-cs"/>
-                </a:rPr>
-                <a:t>能力强弱依赖机型</a:t>
+                    <a:srgbClr val="1F5A49"/>
+                  </a:solidFill>
+                  <a:latin typeface="+mn-lt"/>
+                  <a:ea typeface="+mn-ea"/>
+                  <a:cs typeface="+mn-cs"/>
+                </a:rPr>
+                <a:t>1000万设置；待独立验证</a:t>
               </a:r>
             </a:p>
           </p:txBody>
@@ -3377,7 +3377,7 @@
           <p:spPr>
             <a:xfrm>
               <a:off x="564642" y="4622800"/>
-              <a:ext cx="781812" cy="264033"/>
+              <a:ext cx="1549284" cy="264033"/>
             </a:xfrm>
             <a:prstGeom prst="rect">
               <a:avLst/>
@@ -3403,7 +3403,7 @@
                   <a:ea typeface="+mj-ea"/>
                   <a:cs typeface="+mj-cs"/>
                 </a:rPr>
-                <a:t>超级小爱</a:t>
+                <a:t>Bixby / 超级小爱</a:t>
               </a:r>
             </a:p>
           </p:txBody>
@@ -3417,7 +3417,7 @@
           <p:spPr>
             <a:xfrm>
               <a:off x="2280666" y="4673600"/>
-              <a:ext cx="1735150" cy="205359"/>
+              <a:ext cx="1657407" cy="205359"/>
             </a:xfrm>
             <a:prstGeom prst="rect">
               <a:avLst/>
@@ -3443,7 +3443,7 @@
                   <a:ea typeface="+mn-ea"/>
                   <a:cs typeface="+mn-cs"/>
                 </a:rPr>
-                <a:t>文字/语音/图片/文档/屏幕</a:t>
+                <a:t>相机/文档/圈屏/设备入口</a:t>
               </a:r>
             </a:p>
           </p:txBody>
@@ -3457,7 +3457,7 @@
           <p:spPr>
             <a:xfrm>
               <a:off x="4757166" y="4673600"/>
-              <a:ext cx="1424178" cy="205359"/>
+              <a:ext cx="1706880" cy="205359"/>
             </a:xfrm>
             <a:prstGeom prst="rect">
               <a:avLst/>
@@ -3483,7 +3483,7 @@
                   <a:ea typeface="+mn-ea"/>
                   <a:cs typeface="+mn-cs"/>
                 </a:rPr>
-                <a:t>陪伴、帮看、设备生态</a:t>
+                <a:t>系统任务、陪伴与设备生态</a:t>
               </a:r>
             </a:p>
           </p:txBody>
@@ -3497,7 +3497,7 @@
           <p:spPr>
             <a:xfrm>
               <a:off x="7805166" y="4673600"/>
-              <a:ext cx="1000125" cy="205359"/>
+              <a:ext cx="717423" cy="205359"/>
             </a:xfrm>
             <a:prstGeom prst="rect">
               <a:avLst/>
@@ -3523,7 +3523,7 @@
                   <a:ea typeface="+mn-ea"/>
                   <a:cs typeface="+mn-cs"/>
                 </a:rPr>
-                <a:t>家庭与个人助手</a:t>
+                <a:t>手机与家庭</a:t>
               </a:r>
             </a:p>
           </p:txBody>
@@ -36373,26 +36373,26 @@
           </p:nvSpPr>
           <p:spPr>
             <a:xfrm>
-              <a:off x="565785" y="2279650"/>
-              <a:ext cx="1745635" cy="220028"/>
-            </a:xfrm>
-            <a:prstGeom prst="rect">
-              <a:avLst/>
-            </a:prstGeom>
-            <a:noFill/>
-            <a:ln>
-              <a:noFill/>
-            </a:ln>
-          </p:spPr>
-          <p:txBody>
-            <a:bodyPr wrap="none" lIns="0" tIns="0" rIns="0" bIns="0" anchor="t" anchorCtr="0">
-              <a:spAutoFit/>
-            </a:bodyPr>
-            <a:lstStyle/>
-            <a:p>
-              <a:pPr algn="l"/>
-              <a:r>
-                <a:rPr lang="en-US" sz="1120" dirty="0">
+              <a:off x="566166" y="2292350"/>
+              <a:ext cx="1636485" cy="205359"/>
+            </a:xfrm>
+            <a:prstGeom prst="rect">
+              <a:avLst/>
+            </a:prstGeom>
+            <a:noFill/>
+            <a:ln>
+              <a:noFill/>
+            </a:ln>
+          </p:spPr>
+          <p:txBody>
+            <a:bodyPr wrap="none" lIns="0" tIns="0" rIns="0" bIns="0" anchor="t" anchorCtr="0">
+              <a:spAutoFit/>
+            </a:bodyPr>
+            <a:lstStyle/>
+            <a:p>
+              <a:pPr algn="l"/>
+              <a:r>
+                <a:rPr lang="en-US" sz="1050" dirty="0">
                   <a:solidFill>
                     <a:srgbClr val="3F3B35"/>
                   </a:solidFill>
@@ -36413,26 +36413,26 @@
           </p:nvSpPr>
           <p:spPr>
             <a:xfrm>
-              <a:off x="565785" y="2508250"/>
-              <a:ext cx="1089467" cy="220028"/>
-            </a:xfrm>
-            <a:prstGeom prst="rect">
-              <a:avLst/>
-            </a:prstGeom>
-            <a:noFill/>
-            <a:ln>
-              <a:noFill/>
-            </a:ln>
-          </p:spPr>
-          <p:txBody>
-            <a:bodyPr wrap="none" lIns="0" tIns="0" rIns="0" bIns="0" anchor="t" anchorCtr="0">
-              <a:spAutoFit/>
-            </a:bodyPr>
-            <a:lstStyle/>
-            <a:p>
-              <a:pPr algn="l"/>
-              <a:r>
-                <a:rPr lang="zh-CN" sz="1120" dirty="0">
+              <a:off x="566166" y="2520950"/>
+              <a:ext cx="1530225" cy="205359"/>
+            </a:xfrm>
+            <a:prstGeom prst="rect">
+              <a:avLst/>
+            </a:prstGeom>
+            <a:noFill/>
+            <a:ln>
+              <a:noFill/>
+            </a:ln>
+          </p:spPr>
+          <p:txBody>
+            <a:bodyPr wrap="none" lIns="0" tIns="0" rIns="0" bIns="0" anchor="t" anchorCtr="0">
+              <a:spAutoFit/>
+            </a:bodyPr>
+            <a:lstStyle/>
+            <a:p>
+              <a:pPr algn="l"/>
+              <a:r>
+                <a:rPr lang="zh-CN" sz="1050" dirty="0">
                   <a:solidFill>
                     <a:srgbClr val="3F3B35"/>
                   </a:solidFill>
@@ -36440,7 +36440,7 @@
                   <a:ea typeface="+mn-ea"/>
                   <a:cs typeface="+mn-cs"/>
                 </a:rPr>
-                <a:t>小艺 / 超级小爱</a:t>
+                <a:t>Muse / 小艺 / 超级小爱</a:t>
               </a:r>
             </a:p>
           </p:txBody>

</xml_diff>